<commit_message>
Temporary: updated Tools deck for Canva import
Co-Authored-By: Claude Opus 5.5 (1M context) <noreply@anthropic.com>
Claude-Session: https://claude.ai/code/session_01Gd735ZmLvLEx2EBuuiBLRC
</commit_message>
<xml_diff>
--- a/00-tools.pptx
+++ b/00-tools.pptx
@@ -6129,7 +6129,7 @@
         <p:spPr>
           <a:xfrm>
             <a:off x="914400" y="2762250"/>
-            <a:ext cx="9525000" cy="5715000"/>
+            <a:ext cx="9525000" cy="396240"/>
           </a:xfrm>
           <a:prstGeom prst="rect">
             <a:avLst/>
@@ -6146,9 +6146,6 @@
               <a:lnSpc>
                 <a:spcPct val="125000"/>
               </a:lnSpc>
-              <a:spcAft>
-                <a:spcPts val="2250"/>
-              </a:spcAft>
             </a:pPr>
             <a:r>
               <a:rPr sz="2400" b="1" i="0">
@@ -6195,14 +6192,34 @@
               <a:t> is a folder git is watching</a:t>
             </a:r>
           </a:p>
+        </p:txBody>
+      </p:sp>
+      <p:sp>
+        <p:nvSpPr>
+          <p:cNvPr id="6" name="TextBox 5"/>
+          <p:cNvSpPr txBox="1"/>
+          <p:nvPr/>
+        </p:nvSpPr>
+        <p:spPr>
+          <a:xfrm>
+            <a:off x="914400" y="3444240"/>
+            <a:ext cx="9525000" cy="396240"/>
+          </a:xfrm>
+          <a:prstGeom prst="rect">
+            <a:avLst/>
+          </a:prstGeom>
+          <a:noFill/>
+        </p:spPr>
+        <p:txBody>
+          <a:bodyPr wrap="square" lIns="0" rIns="0" tIns="0" bIns="0" anchor="t">
+            <a:spAutoFit/>
+          </a:bodyPr>
+          <a:lstStyle/>
           <a:p>
             <a:pPr algn="l">
               <a:lnSpc>
                 <a:spcPct val="125000"/>
               </a:lnSpc>
-              <a:spcAft>
-                <a:spcPts val="2250"/>
-              </a:spcAft>
             </a:pPr>
             <a:r>
               <a:rPr sz="2400" b="1" i="0">
@@ -6249,14 +6266,34 @@
               <a:t> is a saved snapshot, with a message</a:t>
             </a:r>
           </a:p>
+        </p:txBody>
+      </p:sp>
+      <p:sp>
+        <p:nvSpPr>
+          <p:cNvPr id="7" name="TextBox 6"/>
+          <p:cNvSpPr txBox="1"/>
+          <p:nvPr/>
+        </p:nvSpPr>
+        <p:spPr>
+          <a:xfrm>
+            <a:off x="914400" y="4126230"/>
+            <a:ext cx="9525000" cy="396240"/>
+          </a:xfrm>
+          <a:prstGeom prst="rect">
+            <a:avLst/>
+          </a:prstGeom>
+          <a:noFill/>
+        </p:spPr>
+        <p:txBody>
+          <a:bodyPr wrap="square" lIns="0" rIns="0" tIns="0" bIns="0" anchor="t">
+            <a:spAutoFit/>
+          </a:bodyPr>
+          <a:lstStyle/>
           <a:p>
             <a:pPr algn="l">
               <a:lnSpc>
                 <a:spcPct val="125000"/>
               </a:lnSpc>
-              <a:spcAft>
-                <a:spcPts val="2250"/>
-              </a:spcAft>
             </a:pPr>
             <a:r>
               <a:rPr sz="2400" b="1" i="0">
@@ -6292,14 +6329,34 @@
               <a:t> picks which changes go in the next commit</a:t>
             </a:r>
           </a:p>
+        </p:txBody>
+      </p:sp>
+      <p:sp>
+        <p:nvSpPr>
+          <p:cNvPr id="8" name="TextBox 7"/>
+          <p:cNvSpPr txBox="1"/>
+          <p:nvPr/>
+        </p:nvSpPr>
+        <p:spPr>
+          <a:xfrm>
+            <a:off x="914400" y="4808220"/>
+            <a:ext cx="9525000" cy="396240"/>
+          </a:xfrm>
+          <a:prstGeom prst="rect">
+            <a:avLst/>
+          </a:prstGeom>
+          <a:noFill/>
+        </p:spPr>
+        <p:txBody>
+          <a:bodyPr wrap="square" lIns="0" rIns="0" tIns="0" bIns="0" anchor="t">
+            <a:spAutoFit/>
+          </a:bodyPr>
+          <a:lstStyle/>
           <a:p>
             <a:pPr algn="l">
               <a:lnSpc>
                 <a:spcPct val="125000"/>
               </a:lnSpc>
-              <a:spcAft>
-                <a:spcPts val="2250"/>
-              </a:spcAft>
             </a:pPr>
             <a:r>
               <a:rPr sz="2400" b="1" i="0">
@@ -6350,7 +6407,7 @@
       </p:sp>
       <p:sp>
         <p:nvSpPr>
-          <p:cNvPr id="6" name="Rounded Rectangle 5"/>
+          <p:cNvPr id="9" name="Rounded Rectangle 8"/>
           <p:cNvSpPr/>
           <p:nvPr/>
         </p:nvSpPr>
@@ -6396,7 +6453,7 @@
       </p:sp>
       <p:pic>
         <p:nvPicPr>
-          <p:cNvPr id="7" name="Picture 6" descr="git.png"/>
+          <p:cNvPr id="10" name="Picture 9" descr="git.png"/>
           <p:cNvPicPr>
             <a:picLocks noChangeAspect="1"/>
           </p:cNvPicPr>
@@ -6420,7 +6477,7 @@
       </p:pic>
       <p:sp>
         <p:nvSpPr>
-          <p:cNvPr id="8" name="TextBox 7"/>
+          <p:cNvPr id="11" name="TextBox 10"/>
           <p:cNvSpPr txBox="1"/>
           <p:nvPr/>
         </p:nvSpPr>
@@ -6457,7 +6514,7 @@
       </p:sp>
       <p:sp>
         <p:nvSpPr>
-          <p:cNvPr id="9" name="TextBox 8"/>
+          <p:cNvPr id="12" name="TextBox 11"/>
           <p:cNvSpPr txBox="1"/>
           <p:nvPr/>
         </p:nvSpPr>
@@ -6498,7 +6555,7 @@
       </p:sp>
       <p:pic>
         <p:nvPicPr>
-          <p:cNvPr id="10" name="Picture 9" descr="mw_logo_small.png"/>
+          <p:cNvPr id="13" name="Picture 12" descr="mw_logo_small.png"/>
           <p:cNvPicPr>
             <a:picLocks noChangeAspect="1"/>
           </p:cNvPicPr>
@@ -6522,7 +6579,7 @@
       </p:pic>
       <p:sp>
         <p:nvSpPr>
-          <p:cNvPr id="11" name="TextBox 10"/>
+          <p:cNvPr id="14" name="TextBox 13"/>
           <p:cNvSpPr txBox="1"/>
           <p:nvPr/>
         </p:nvSpPr>
@@ -10244,7 +10301,7 @@
         <p:spPr>
           <a:xfrm>
             <a:off x="1371600" y="4476750"/>
-            <a:ext cx="7239000" cy="3429000"/>
+            <a:ext cx="7239000" cy="371475"/>
           </a:xfrm>
           <a:prstGeom prst="rect">
             <a:avLst/>
@@ -10261,9 +10318,6 @@
               <a:lnSpc>
                 <a:spcPct val="125000"/>
               </a:lnSpc>
-              <a:spcAft>
-                <a:spcPts val="1950"/>
-              </a:spcAft>
             </a:pPr>
             <a:r>
               <a:rPr sz="2250" b="1" i="0">
@@ -10288,14 +10342,34 @@
               <a:t>Joins a finished branch into the one you're on</a:t>
             </a:r>
           </a:p>
+        </p:txBody>
+      </p:sp>
+      <p:sp>
+        <p:nvSpPr>
+          <p:cNvPr id="9" name="TextBox 8"/>
+          <p:cNvSpPr txBox="1"/>
+          <p:nvPr/>
+        </p:nvSpPr>
+        <p:spPr>
+          <a:xfrm>
+            <a:off x="1371600" y="5076825"/>
+            <a:ext cx="7239000" cy="371475"/>
+          </a:xfrm>
+          <a:prstGeom prst="rect">
+            <a:avLst/>
+          </a:prstGeom>
+          <a:noFill/>
+        </p:spPr>
+        <p:txBody>
+          <a:bodyPr wrap="square" lIns="0" rIns="0" tIns="0" bIns="0" anchor="t">
+            <a:spAutoFit/>
+          </a:bodyPr>
+          <a:lstStyle/>
           <a:p>
             <a:pPr algn="l">
               <a:lnSpc>
                 <a:spcPct val="125000"/>
               </a:lnSpc>
-              <a:spcAft>
-                <a:spcPts val="1950"/>
-              </a:spcAft>
             </a:pPr>
             <a:r>
               <a:rPr sz="2250" b="1" i="0">
@@ -10320,14 +10394,34 @@
               <a:t>Keeps both histories as they were</a:t>
             </a:r>
           </a:p>
+        </p:txBody>
+      </p:sp>
+      <p:sp>
+        <p:nvSpPr>
+          <p:cNvPr id="10" name="TextBox 9"/>
+          <p:cNvSpPr txBox="1"/>
+          <p:nvPr/>
+        </p:nvSpPr>
+        <p:spPr>
+          <a:xfrm>
+            <a:off x="1371600" y="5676900"/>
+            <a:ext cx="7239000" cy="371475"/>
+          </a:xfrm>
+          <a:prstGeom prst="rect">
+            <a:avLst/>
+          </a:prstGeom>
+          <a:noFill/>
+        </p:spPr>
+        <p:txBody>
+          <a:bodyPr wrap="square" lIns="0" rIns="0" tIns="0" bIns="0" anchor="t">
+            <a:spAutoFit/>
+          </a:bodyPr>
+          <a:lstStyle/>
           <a:p>
             <a:pPr algn="l">
               <a:lnSpc>
                 <a:spcPct val="125000"/>
               </a:lnSpc>
-              <a:spcAft>
-                <a:spcPts val="1950"/>
-              </a:spcAft>
             </a:pPr>
             <a:r>
               <a:rPr sz="2250" b="1" i="0">
@@ -10356,7 +10450,7 @@
       </p:sp>
       <p:sp>
         <p:nvSpPr>
-          <p:cNvPr id="9" name="Rounded Rectangle 8"/>
+          <p:cNvPr id="11" name="Rounded Rectangle 10"/>
           <p:cNvSpPr/>
           <p:nvPr/>
         </p:nvSpPr>
@@ -10402,7 +10496,7 @@
       </p:sp>
       <p:sp>
         <p:nvSpPr>
-          <p:cNvPr id="10" name="TextBox 9"/>
+          <p:cNvPr id="12" name="TextBox 11"/>
           <p:cNvSpPr txBox="1"/>
           <p:nvPr/>
         </p:nvSpPr>
@@ -10439,7 +10533,7 @@
       </p:sp>
       <p:sp>
         <p:nvSpPr>
-          <p:cNvPr id="11" name="Rectangle 10"/>
+          <p:cNvPr id="13" name="Rectangle 12"/>
           <p:cNvSpPr/>
           <p:nvPr/>
         </p:nvSpPr>
@@ -10481,14 +10575,14 @@
       </p:sp>
       <p:sp>
         <p:nvSpPr>
-          <p:cNvPr id="12" name="TextBox 11"/>
+          <p:cNvPr id="14" name="TextBox 13"/>
           <p:cNvSpPr txBox="1"/>
           <p:nvPr/>
         </p:nvSpPr>
         <p:spPr>
           <a:xfrm>
             <a:off x="9791700" y="4476750"/>
-            <a:ext cx="7239000" cy="3429000"/>
+            <a:ext cx="7239000" cy="371475"/>
           </a:xfrm>
           <a:prstGeom prst="rect">
             <a:avLst/>
@@ -10505,9 +10599,6 @@
               <a:lnSpc>
                 <a:spcPct val="125000"/>
               </a:lnSpc>
-              <a:spcAft>
-                <a:spcPts val="1950"/>
-              </a:spcAft>
             </a:pPr>
             <a:r>
               <a:rPr sz="2250" b="1" i="0">
@@ -10532,14 +10623,34 @@
               <a:t>Replays your commits on develop's newest one</a:t>
             </a:r>
           </a:p>
+        </p:txBody>
+      </p:sp>
+      <p:sp>
+        <p:nvSpPr>
+          <p:cNvPr id="15" name="TextBox 14"/>
+          <p:cNvSpPr txBox="1"/>
+          <p:nvPr/>
+        </p:nvSpPr>
+        <p:spPr>
+          <a:xfrm>
+            <a:off x="9791700" y="5076825"/>
+            <a:ext cx="7239000" cy="371475"/>
+          </a:xfrm>
+          <a:prstGeom prst="rect">
+            <a:avLst/>
+          </a:prstGeom>
+          <a:noFill/>
+        </p:spPr>
+        <p:txBody>
+          <a:bodyPr wrap="square" lIns="0" rIns="0" tIns="0" bIns="0" anchor="t">
+            <a:spAutoFit/>
+          </a:bodyPr>
+          <a:lstStyle/>
           <a:p>
             <a:pPr algn="l">
               <a:lnSpc>
                 <a:spcPct val="125000"/>
               </a:lnSpc>
-              <a:spcAft>
-                <a:spcPts val="1950"/>
-              </a:spcAft>
             </a:pPr>
             <a:r>
               <a:rPr sz="2250" b="1" i="0">
@@ -10564,14 +10675,34 @@
               <a:t>History becomes one straight line</a:t>
             </a:r>
           </a:p>
+        </p:txBody>
+      </p:sp>
+      <p:sp>
+        <p:nvSpPr>
+          <p:cNvPr id="16" name="TextBox 15"/>
+          <p:cNvSpPr txBox="1"/>
+          <p:nvPr/>
+        </p:nvSpPr>
+        <p:spPr>
+          <a:xfrm>
+            <a:off x="9791700" y="5676900"/>
+            <a:ext cx="7239000" cy="371475"/>
+          </a:xfrm>
+          <a:prstGeom prst="rect">
+            <a:avLst/>
+          </a:prstGeom>
+          <a:noFill/>
+        </p:spPr>
+        <p:txBody>
+          <a:bodyPr wrap="square" lIns="0" rIns="0" tIns="0" bIns="0" anchor="t">
+            <a:spAutoFit/>
+          </a:bodyPr>
+          <a:lstStyle/>
           <a:p>
             <a:pPr algn="l">
               <a:lnSpc>
                 <a:spcPct val="125000"/>
               </a:lnSpc>
-              <a:spcAft>
-                <a:spcPts val="1950"/>
-              </a:spcAft>
             </a:pPr>
             <a:r>
               <a:rPr sz="2250" b="1" i="0">
@@ -10600,7 +10731,7 @@
       </p:sp>
       <p:pic>
         <p:nvPicPr>
-          <p:cNvPr id="13" name="Picture 12" descr="mw_logo_small.png"/>
+          <p:cNvPr id="17" name="Picture 16" descr="mw_logo_small.png"/>
           <p:cNvPicPr>
             <a:picLocks noChangeAspect="1"/>
           </p:cNvPicPr>
@@ -10624,7 +10755,7 @@
       </p:pic>
       <p:sp>
         <p:nvSpPr>
-          <p:cNvPr id="14" name="TextBox 13"/>
+          <p:cNvPr id="18" name="TextBox 17"/>
           <p:cNvSpPr txBox="1"/>
           <p:nvPr/>
         </p:nvSpPr>
@@ -10864,7 +10995,7 @@
         <p:spPr>
           <a:xfrm>
             <a:off x="1371600" y="3314700"/>
-            <a:ext cx="762000" cy="762000"/>
+            <a:ext cx="1108364" cy="762000"/>
           </a:xfrm>
           <a:prstGeom prst="rect">
             <a:avLst/>
@@ -11049,7 +11180,7 @@
         <p:spPr>
           <a:xfrm>
             <a:off x="6981825" y="3314700"/>
-            <a:ext cx="762000" cy="762000"/>
+            <a:ext cx="609600" cy="762000"/>
           </a:xfrm>
           <a:prstGeom prst="rect">
             <a:avLst/>
@@ -11234,7 +11365,7 @@
         <p:spPr>
           <a:xfrm>
             <a:off x="12592050" y="3314700"/>
-            <a:ext cx="762000" cy="762000"/>
+            <a:ext cx="870857" cy="762000"/>
           </a:xfrm>
           <a:prstGeom prst="rect">
             <a:avLst/>
@@ -12649,7 +12780,7 @@
         <p:spPr>
           <a:xfrm>
             <a:off x="914400" y="2762250"/>
-            <a:ext cx="7048500" cy="5715000"/>
+            <a:ext cx="7048500" cy="371475"/>
           </a:xfrm>
           <a:prstGeom prst="rect">
             <a:avLst/>
@@ -12666,9 +12797,6 @@
               <a:lnSpc>
                 <a:spcPct val="125000"/>
               </a:lnSpc>
-              <a:spcAft>
-                <a:spcPts val="2550"/>
-              </a:spcAft>
             </a:pPr>
             <a:r>
               <a:rPr sz="2250" b="1" i="0">
@@ -12693,14 +12821,34 @@
               <a:t>Every value the robot publishes is a field</a:t>
             </a:r>
           </a:p>
+        </p:txBody>
+      </p:sp>
+      <p:sp>
+        <p:nvSpPr>
+          <p:cNvPr id="6" name="TextBox 5"/>
+          <p:cNvSpPr txBox="1"/>
+          <p:nvPr/>
+        </p:nvSpPr>
+        <p:spPr>
+          <a:xfrm>
+            <a:off x="914400" y="3457575"/>
+            <a:ext cx="7048500" cy="371475"/>
+          </a:xfrm>
+          <a:prstGeom prst="rect">
+            <a:avLst/>
+          </a:prstGeom>
+          <a:noFill/>
+        </p:spPr>
+        <p:txBody>
+          <a:bodyPr wrap="square" lIns="0" rIns="0" tIns="0" bIns="0" anchor="t">
+            <a:spAutoFit/>
+          </a:bodyPr>
+          <a:lstStyle/>
           <a:p>
             <a:pPr algn="l">
               <a:lnSpc>
                 <a:spcPct val="125000"/>
               </a:lnSpc>
-              <a:spcAft>
-                <a:spcPts val="2550"/>
-              </a:spcAft>
             </a:pPr>
             <a:r>
               <a:rPr sz="2250" b="1" i="0">
@@ -12725,14 +12873,34 @@
               <a:t>Drag a field onto a tab to graph or draw it</a:t>
             </a:r>
           </a:p>
+        </p:txBody>
+      </p:sp>
+      <p:sp>
+        <p:nvSpPr>
+          <p:cNvPr id="7" name="TextBox 6"/>
+          <p:cNvSpPr txBox="1"/>
+          <p:nvPr/>
+        </p:nvSpPr>
+        <p:spPr>
+          <a:xfrm>
+            <a:off x="914400" y="4152900"/>
+            <a:ext cx="7048500" cy="371475"/>
+          </a:xfrm>
+          <a:prstGeom prst="rect">
+            <a:avLst/>
+          </a:prstGeom>
+          <a:noFill/>
+        </p:spPr>
+        <p:txBody>
+          <a:bodyPr wrap="square" lIns="0" rIns="0" tIns="0" bIns="0" anchor="t">
+            <a:spAutoFit/>
+          </a:bodyPr>
+          <a:lstStyle/>
           <a:p>
             <a:pPr algn="l">
               <a:lnSpc>
                 <a:spcPct val="125000"/>
               </a:lnSpc>
-              <a:spcAft>
-                <a:spcPts val="2550"/>
-              </a:spcAft>
             </a:pPr>
             <a:r>
               <a:rPr sz="2250" b="1" i="0">
@@ -12757,14 +12925,34 @@
               <a:t>Live data: Start and Enable the robot first</a:t>
             </a:r>
           </a:p>
+        </p:txBody>
+      </p:sp>
+      <p:sp>
+        <p:nvSpPr>
+          <p:cNvPr id="8" name="TextBox 7"/>
+          <p:cNvSpPr txBox="1"/>
+          <p:nvPr/>
+        </p:nvSpPr>
+        <p:spPr>
+          <a:xfrm>
+            <a:off x="914400" y="4848225"/>
+            <a:ext cx="7048500" cy="371475"/>
+          </a:xfrm>
+          <a:prstGeom prst="rect">
+            <a:avLst/>
+          </a:prstGeom>
+          <a:noFill/>
+        </p:spPr>
+        <p:txBody>
+          <a:bodyPr wrap="square" lIns="0" rIns="0" tIns="0" bIns="0" anchor="t">
+            <a:spAutoFit/>
+          </a:bodyPr>
+          <a:lstStyle/>
           <a:p>
             <a:pPr algn="l">
               <a:lnSpc>
                 <a:spcPct val="125000"/>
               </a:lnSpc>
-              <a:spcAft>
-                <a:spcPts val="2550"/>
-              </a:spcAft>
             </a:pPr>
             <a:r>
               <a:rPr sz="2250" b="1" i="0">
@@ -12793,7 +12981,7 @@
       </p:sp>
       <p:sp>
         <p:nvSpPr>
-          <p:cNvPr id="6" name="Rectangle 5"/>
+          <p:cNvPr id="9" name="Rectangle 8"/>
           <p:cNvSpPr/>
           <p:nvPr/>
         </p:nvSpPr>
@@ -12837,7 +13025,7 @@
       </p:sp>
       <p:pic>
         <p:nvPicPr>
-          <p:cNvPr id="7" name="Picture 6" descr="ascope.jpg"/>
+          <p:cNvPr id="10" name="Picture 9" descr="ascope.jpg"/>
           <p:cNvPicPr>
             <a:picLocks noChangeAspect="1"/>
           </p:cNvPicPr>
@@ -12861,7 +13049,7 @@
       </p:pic>
       <p:sp>
         <p:nvSpPr>
-          <p:cNvPr id="8" name="Rectangle 7"/>
+          <p:cNvPr id="11" name="Rectangle 10"/>
           <p:cNvSpPr/>
           <p:nvPr/>
         </p:nvSpPr>
@@ -12903,7 +13091,7 @@
       </p:sp>
       <p:sp>
         <p:nvSpPr>
-          <p:cNvPr id="9" name="TextBox 8"/>
+          <p:cNvPr id="12" name="TextBox 11"/>
           <p:cNvSpPr txBox="1"/>
           <p:nvPr/>
         </p:nvSpPr>
@@ -12940,7 +13128,7 @@
       </p:sp>
       <p:pic>
         <p:nvPicPr>
-          <p:cNvPr id="10" name="Picture 9" descr="mw_logo_small.png"/>
+          <p:cNvPr id="13" name="Picture 12" descr="mw_logo_small.png"/>
           <p:cNvPicPr>
             <a:picLocks noChangeAspect="1"/>
           </p:cNvPicPr>
@@ -12964,7 +13152,7 @@
       </p:pic>
       <p:sp>
         <p:nvSpPr>
-          <p:cNvPr id="11" name="TextBox 10"/>
+          <p:cNvPr id="14" name="TextBox 13"/>
           <p:cNvSpPr txBox="1"/>
           <p:nvPr/>
         </p:nvSpPr>
@@ -14994,7 +15182,7 @@
         <p:spPr>
           <a:xfrm>
             <a:off x="1333500" y="7410450"/>
-            <a:ext cx="609600" cy="609600"/>
+            <a:ext cx="650240" cy="609600"/>
           </a:xfrm>
           <a:prstGeom prst="rect">
             <a:avLst/>
@@ -16309,7 +16497,7 @@
         <p:spPr>
           <a:xfrm>
             <a:off x="914400" y="2762250"/>
-            <a:ext cx="7048500" cy="5715000"/>
+            <a:ext cx="7048500" cy="371475"/>
           </a:xfrm>
           <a:prstGeom prst="rect">
             <a:avLst/>
@@ -16326,9 +16514,6 @@
               <a:lnSpc>
                 <a:spcPct val="125000"/>
               </a:lnSpc>
-              <a:spcAft>
-                <a:spcPts val="2550"/>
-              </a:spcAft>
             </a:pPr>
             <a:r>
               <a:rPr sz="2250" b="1" i="0">
@@ -16353,14 +16538,34 @@
               <a:t>Widgets show live robot values, called topics</a:t>
             </a:r>
           </a:p>
+        </p:txBody>
+      </p:sp>
+      <p:sp>
+        <p:nvSpPr>
+          <p:cNvPr id="6" name="TextBox 5"/>
+          <p:cNvSpPr txBox="1"/>
+          <p:nvPr/>
+        </p:nvSpPr>
+        <p:spPr>
+          <a:xfrm>
+            <a:off x="914400" y="3457575"/>
+            <a:ext cx="7048500" cy="371475"/>
+          </a:xfrm>
+          <a:prstGeom prst="rect">
+            <a:avLst/>
+          </a:prstGeom>
+          <a:noFill/>
+        </p:spPr>
+        <p:txBody>
+          <a:bodyPr wrap="square" lIns="0" rIns="0" tIns="0" bIns="0" anchor="t">
+            <a:spAutoFit/>
+          </a:bodyPr>
+          <a:lstStyle/>
           <a:p>
             <a:pPr algn="l">
               <a:lnSpc>
                 <a:spcPct val="125000"/>
               </a:lnSpc>
-              <a:spcAft>
-                <a:spcPts val="2550"/>
-              </a:spcAft>
             </a:pPr>
             <a:r>
               <a:rPr sz="2250" b="1" i="0">
@@ -16385,14 +16590,34 @@
               <a:t>Start the robot; look for Connected</a:t>
             </a:r>
           </a:p>
+        </p:txBody>
+      </p:sp>
+      <p:sp>
+        <p:nvSpPr>
+          <p:cNvPr id="7" name="TextBox 6"/>
+          <p:cNvSpPr txBox="1"/>
+          <p:nvPr/>
+        </p:nvSpPr>
+        <p:spPr>
+          <a:xfrm>
+            <a:off x="914400" y="4152900"/>
+            <a:ext cx="7048500" cy="371475"/>
+          </a:xfrm>
+          <a:prstGeom prst="rect">
+            <a:avLst/>
+          </a:prstGeom>
+          <a:noFill/>
+        </p:spPr>
+        <p:txBody>
+          <a:bodyPr wrap="square" lIns="0" rIns="0" tIns="0" bIns="0" anchor="t">
+            <a:spAutoFit/>
+          </a:bodyPr>
+          <a:lstStyle/>
           <a:p>
             <a:pPr algn="l">
               <a:lnSpc>
                 <a:spcPct val="125000"/>
               </a:lnSpc>
-              <a:spcAft>
-                <a:spcPts val="2550"/>
-              </a:spcAft>
             </a:pPr>
             <a:r>
               <a:rPr sz="2250" b="1" i="0">
@@ -16417,14 +16642,34 @@
               <a:t>Add Widget, then drag a topic onto the grid</a:t>
             </a:r>
           </a:p>
+        </p:txBody>
+      </p:sp>
+      <p:sp>
+        <p:nvSpPr>
+          <p:cNvPr id="8" name="TextBox 7"/>
+          <p:cNvSpPr txBox="1"/>
+          <p:nvPr/>
+        </p:nvSpPr>
+        <p:spPr>
+          <a:xfrm>
+            <a:off x="914400" y="4848225"/>
+            <a:ext cx="7048500" cy="371475"/>
+          </a:xfrm>
+          <a:prstGeom prst="rect">
+            <a:avLst/>
+          </a:prstGeom>
+          <a:noFill/>
+        </p:spPr>
+        <p:txBody>
+          <a:bodyPr wrap="square" lIns="0" rIns="0" tIns="0" bIns="0" anchor="t">
+            <a:spAutoFit/>
+          </a:bodyPr>
+          <a:lstStyle/>
           <a:p>
             <a:pPr algn="l">
               <a:lnSpc>
                 <a:spcPct val="125000"/>
               </a:lnSpc>
-              <a:spcAft>
-                <a:spcPts val="2550"/>
-              </a:spcAft>
             </a:pPr>
             <a:r>
               <a:rPr sz="2250" b="1" i="0">
@@ -16453,7 +16698,7 @@
       </p:sp>
       <p:sp>
         <p:nvSpPr>
-          <p:cNvPr id="6" name="Rectangle 5"/>
+          <p:cNvPr id="9" name="Rectangle 8"/>
           <p:cNvSpPr/>
           <p:nvPr/>
         </p:nvSpPr>
@@ -16497,7 +16742,7 @@
       </p:sp>
       <p:pic>
         <p:nvPicPr>
-          <p:cNvPr id="7" name="Picture 6" descr="elastic.png"/>
+          <p:cNvPr id="10" name="Picture 9" descr="elastic.png"/>
           <p:cNvPicPr>
             <a:picLocks noChangeAspect="1"/>
           </p:cNvPicPr>
@@ -16521,7 +16766,7 @@
       </p:pic>
       <p:sp>
         <p:nvSpPr>
-          <p:cNvPr id="8" name="Rectangle 7"/>
+          <p:cNvPr id="11" name="Rectangle 10"/>
           <p:cNvSpPr/>
           <p:nvPr/>
         </p:nvSpPr>
@@ -16563,7 +16808,7 @@
       </p:sp>
       <p:sp>
         <p:nvSpPr>
-          <p:cNvPr id="9" name="TextBox 8"/>
+          <p:cNvPr id="12" name="TextBox 11"/>
           <p:cNvSpPr txBox="1"/>
           <p:nvPr/>
         </p:nvSpPr>
@@ -16600,7 +16845,7 @@
       </p:sp>
       <p:pic>
         <p:nvPicPr>
-          <p:cNvPr id="10" name="Picture 9" descr="mw_logo_small.png"/>
+          <p:cNvPr id="13" name="Picture 12" descr="mw_logo_small.png"/>
           <p:cNvPicPr>
             <a:picLocks noChangeAspect="1"/>
           </p:cNvPicPr>
@@ -16624,7 +16869,7 @@
       </p:pic>
       <p:sp>
         <p:nvSpPr>
-          <p:cNvPr id="11" name="TextBox 10"/>
+          <p:cNvPr id="14" name="TextBox 13"/>
           <p:cNvSpPr txBox="1"/>
           <p:nvPr/>
         </p:nvSpPr>
@@ -16930,7 +17175,7 @@
         <p:spPr>
           <a:xfrm>
             <a:off x="1371600" y="4667250"/>
-            <a:ext cx="7239000" cy="3429000"/>
+            <a:ext cx="7239000" cy="371475"/>
           </a:xfrm>
           <a:prstGeom prst="rect">
             <a:avLst/>
@@ -16947,9 +17192,6 @@
               <a:lnSpc>
                 <a:spcPct val="125000"/>
               </a:lnSpc>
-              <a:spcAft>
-                <a:spcPts val="1650"/>
-              </a:spcAft>
             </a:pPr>
             <a:r>
               <a:rPr sz="2250" b="1" i="0">
@@ -16974,14 +17216,34 @@
               <a:t>Text Display, Large Text Display</a:t>
             </a:r>
           </a:p>
+        </p:txBody>
+      </p:sp>
+      <p:sp>
+        <p:nvSpPr>
+          <p:cNvPr id="9" name="TextBox 8"/>
+          <p:cNvSpPr txBox="1"/>
+          <p:nvPr/>
+        </p:nvSpPr>
+        <p:spPr>
+          <a:xfrm>
+            <a:off x="1371600" y="5248275"/>
+            <a:ext cx="7239000" cy="371475"/>
+          </a:xfrm>
+          <a:prstGeom prst="rect">
+            <a:avLst/>
+          </a:prstGeom>
+          <a:noFill/>
+        </p:spPr>
+        <p:txBody>
+          <a:bodyPr wrap="square" lIns="0" rIns="0" tIns="0" bIns="0" anchor="t">
+            <a:spAutoFit/>
+          </a:bodyPr>
+          <a:lstStyle/>
           <a:p>
             <a:pPr algn="l">
               <a:lnSpc>
                 <a:spcPct val="125000"/>
               </a:lnSpc>
-              <a:spcAft>
-                <a:spcPts val="1650"/>
-              </a:spcAft>
             </a:pPr>
             <a:r>
               <a:rPr sz="2250" b="1" i="0">
@@ -17006,14 +17268,34 @@
               <a:t>Number Bar, Voltage View</a:t>
             </a:r>
           </a:p>
+        </p:txBody>
+      </p:sp>
+      <p:sp>
+        <p:nvSpPr>
+          <p:cNvPr id="10" name="TextBox 9"/>
+          <p:cNvSpPr txBox="1"/>
+          <p:nvPr/>
+        </p:nvSpPr>
+        <p:spPr>
+          <a:xfrm>
+            <a:off x="1371600" y="5829300"/>
+            <a:ext cx="7239000" cy="371475"/>
+          </a:xfrm>
+          <a:prstGeom prst="rect">
+            <a:avLst/>
+          </a:prstGeom>
+          <a:noFill/>
+        </p:spPr>
+        <p:txBody>
+          <a:bodyPr wrap="square" lIns="0" rIns="0" tIns="0" bIns="0" anchor="t">
+            <a:spAutoFit/>
+          </a:bodyPr>
+          <a:lstStyle/>
           <a:p>
             <a:pPr algn="l">
               <a:lnSpc>
                 <a:spcPct val="125000"/>
               </a:lnSpc>
-              <a:spcAft>
-                <a:spcPts val="1650"/>
-              </a:spcAft>
             </a:pPr>
             <a:r>
               <a:rPr sz="2250" b="1" i="0">
@@ -17038,14 +17320,34 @@
               <a:t>Radial Gauge, Graph, Match Time</a:t>
             </a:r>
           </a:p>
+        </p:txBody>
+      </p:sp>
+      <p:sp>
+        <p:nvSpPr>
+          <p:cNvPr id="11" name="TextBox 10"/>
+          <p:cNvSpPr txBox="1"/>
+          <p:nvPr/>
+        </p:nvSpPr>
+        <p:spPr>
+          <a:xfrm>
+            <a:off x="1371600" y="6410325"/>
+            <a:ext cx="7239000" cy="371475"/>
+          </a:xfrm>
+          <a:prstGeom prst="rect">
+            <a:avLst/>
+          </a:prstGeom>
+          <a:noFill/>
+        </p:spPr>
+        <p:txBody>
+          <a:bodyPr wrap="square" lIns="0" rIns="0" tIns="0" bIns="0" anchor="t">
+            <a:spAutoFit/>
+          </a:bodyPr>
+          <a:lstStyle/>
           <a:p>
             <a:pPr algn="l">
               <a:lnSpc>
                 <a:spcPct val="125000"/>
               </a:lnSpc>
-              <a:spcAft>
-                <a:spcPts val="1650"/>
-              </a:spcAft>
             </a:pPr>
             <a:r>
               <a:rPr sz="2250" b="1" i="0">
@@ -17074,7 +17376,7 @@
       </p:sp>
       <p:sp>
         <p:nvSpPr>
-          <p:cNvPr id="9" name="Rounded Rectangle 8"/>
+          <p:cNvPr id="12" name="Rounded Rectangle 11"/>
           <p:cNvSpPr/>
           <p:nvPr/>
         </p:nvSpPr>
@@ -17120,7 +17422,7 @@
       </p:sp>
       <p:sp>
         <p:nvSpPr>
-          <p:cNvPr id="10" name="TextBox 9"/>
+          <p:cNvPr id="13" name="TextBox 12"/>
           <p:cNvSpPr txBox="1"/>
           <p:nvPr/>
         </p:nvSpPr>
@@ -17157,7 +17459,7 @@
       </p:sp>
       <p:sp>
         <p:nvSpPr>
-          <p:cNvPr id="11" name="TextBox 10"/>
+          <p:cNvPr id="14" name="TextBox 13"/>
           <p:cNvSpPr txBox="1"/>
           <p:nvPr/>
         </p:nvSpPr>
@@ -17194,14 +17496,14 @@
       </p:sp>
       <p:sp>
         <p:nvSpPr>
-          <p:cNvPr id="12" name="TextBox 11"/>
+          <p:cNvPr id="15" name="TextBox 14"/>
           <p:cNvSpPr txBox="1"/>
           <p:nvPr/>
         </p:nvSpPr>
         <p:spPr>
           <a:xfrm>
             <a:off x="9791700" y="4667250"/>
-            <a:ext cx="7239000" cy="3429000"/>
+            <a:ext cx="7239000" cy="371475"/>
           </a:xfrm>
           <a:prstGeom prst="rect">
             <a:avLst/>
@@ -17218,9 +17520,6 @@
               <a:lnSpc>
                 <a:spcPct val="125000"/>
               </a:lnSpc>
-              <a:spcAft>
-                <a:spcPts val="1650"/>
-              </a:spcAft>
             </a:pPr>
             <a:r>
               <a:rPr sz="2250" b="1" i="0">
@@ -17245,14 +17544,34 @@
               <a:t>Number Slider</a:t>
             </a:r>
           </a:p>
+        </p:txBody>
+      </p:sp>
+      <p:sp>
+        <p:nvSpPr>
+          <p:cNvPr id="16" name="TextBox 15"/>
+          <p:cNvSpPr txBox="1"/>
+          <p:nvPr/>
+        </p:nvSpPr>
+        <p:spPr>
+          <a:xfrm>
+            <a:off x="9791700" y="5248275"/>
+            <a:ext cx="7239000" cy="371475"/>
+          </a:xfrm>
+          <a:prstGeom prst="rect">
+            <a:avLst/>
+          </a:prstGeom>
+          <a:noFill/>
+        </p:spPr>
+        <p:txBody>
+          <a:bodyPr wrap="square" lIns="0" rIns="0" tIns="0" bIns="0" anchor="t">
+            <a:spAutoFit/>
+          </a:bodyPr>
+          <a:lstStyle/>
           <a:p>
             <a:pPr algn="l">
               <a:lnSpc>
                 <a:spcPct val="125000"/>
               </a:lnSpc>
-              <a:spcAft>
-                <a:spcPts val="1650"/>
-              </a:spcAft>
             </a:pPr>
             <a:r>
               <a:rPr sz="2250" b="1" i="0">
@@ -17277,14 +17596,34 @@
               <a:t>ComboBox and Split Button Choosers</a:t>
             </a:r>
           </a:p>
+        </p:txBody>
+      </p:sp>
+      <p:sp>
+        <p:nvSpPr>
+          <p:cNvPr id="17" name="TextBox 16"/>
+          <p:cNvSpPr txBox="1"/>
+          <p:nvPr/>
+        </p:nvSpPr>
+        <p:spPr>
+          <a:xfrm>
+            <a:off x="9791700" y="5829300"/>
+            <a:ext cx="7239000" cy="371475"/>
+          </a:xfrm>
+          <a:prstGeom prst="rect">
+            <a:avLst/>
+          </a:prstGeom>
+          <a:noFill/>
+        </p:spPr>
+        <p:txBody>
+          <a:bodyPr wrap="square" lIns="0" rIns="0" tIns="0" bIns="0" anchor="t">
+            <a:spAutoFit/>
+          </a:bodyPr>
+          <a:lstStyle/>
           <a:p>
             <a:pPr algn="l">
               <a:lnSpc>
                 <a:spcPct val="125000"/>
               </a:lnSpc>
-              <a:spcAft>
-                <a:spcPts val="1650"/>
-              </a:spcAft>
             </a:pPr>
             <a:r>
               <a:rPr sz="2250" b="1" i="0">
@@ -17309,14 +17648,34 @@
               <a:t>Text Display with a Submit button</a:t>
             </a:r>
           </a:p>
+        </p:txBody>
+      </p:sp>
+      <p:sp>
+        <p:nvSpPr>
+          <p:cNvPr id="18" name="TextBox 17"/>
+          <p:cNvSpPr txBox="1"/>
+          <p:nvPr/>
+        </p:nvSpPr>
+        <p:spPr>
+          <a:xfrm>
+            <a:off x="9791700" y="6410325"/>
+            <a:ext cx="7239000" cy="371475"/>
+          </a:xfrm>
+          <a:prstGeom prst="rect">
+            <a:avLst/>
+          </a:prstGeom>
+          <a:noFill/>
+        </p:spPr>
+        <p:txBody>
+          <a:bodyPr wrap="square" lIns="0" rIns="0" tIns="0" bIns="0" anchor="t">
+            <a:spAutoFit/>
+          </a:bodyPr>
+          <a:lstStyle/>
           <a:p>
             <a:pPr algn="l">
               <a:lnSpc>
                 <a:spcPct val="125000"/>
               </a:lnSpc>
-              <a:spcAft>
-                <a:spcPts val="1650"/>
-              </a:spcAft>
             </a:pPr>
             <a:r>
               <a:rPr sz="2250" b="1" i="0">
@@ -17345,7 +17704,7 @@
       </p:sp>
       <p:pic>
         <p:nvPicPr>
-          <p:cNvPr id="13" name="Picture 12" descr="mw_logo_small.png"/>
+          <p:cNvPr id="19" name="Picture 18" descr="mw_logo_small.png"/>
           <p:cNvPicPr>
             <a:picLocks noChangeAspect="1"/>
           </p:cNvPicPr>
@@ -17369,7 +17728,7 @@
       </p:pic>
       <p:sp>
         <p:nvSpPr>
-          <p:cNvPr id="14" name="TextBox 13"/>
+          <p:cNvPr id="20" name="TextBox 19"/>
           <p:cNvSpPr txBox="1"/>
           <p:nvPr/>
         </p:nvSpPr>
@@ -18965,7 +19324,7 @@
         <p:spPr>
           <a:xfrm>
             <a:off x="914400" y="2762250"/>
-            <a:ext cx="7239000" cy="5715000"/>
+            <a:ext cx="7239000" cy="371475"/>
           </a:xfrm>
           <a:prstGeom prst="rect">
             <a:avLst/>
@@ -18982,9 +19341,6 @@
               <a:lnSpc>
                 <a:spcPct val="125000"/>
               </a:lnSpc>
-              <a:spcAft>
-                <a:spcPts val="2550"/>
-              </a:spcAft>
             </a:pPr>
             <a:r>
               <a:rPr sz="2250" b="1" i="0">
@@ -19020,14 +19376,34 @@
               <a:t>: points the path goes through</a:t>
             </a:r>
           </a:p>
+        </p:txBody>
+      </p:sp>
+      <p:sp>
+        <p:nvSpPr>
+          <p:cNvPr id="6" name="TextBox 5"/>
+          <p:cNvSpPr txBox="1"/>
+          <p:nvPr/>
+        </p:nvSpPr>
+        <p:spPr>
+          <a:xfrm>
+            <a:off x="914400" y="3457575"/>
+            <a:ext cx="7239000" cy="742950"/>
+          </a:xfrm>
+          <a:prstGeom prst="rect">
+            <a:avLst/>
+          </a:prstGeom>
+          <a:noFill/>
+        </p:spPr>
+        <p:txBody>
+          <a:bodyPr wrap="square" lIns="0" rIns="0" tIns="0" bIns="0" anchor="t">
+            <a:spAutoFit/>
+          </a:bodyPr>
+          <a:lstStyle/>
           <a:p>
             <a:pPr algn="l">
               <a:lnSpc>
                 <a:spcPct val="125000"/>
               </a:lnSpc>
-              <a:spcAft>
-                <a:spcPts val="2550"/>
-              </a:spcAft>
             </a:pPr>
             <a:r>
               <a:rPr sz="2250" b="1" i="0">
@@ -19085,14 +19461,34 @@
               <a:t> only position</a:t>
             </a:r>
           </a:p>
+        </p:txBody>
+      </p:sp>
+      <p:sp>
+        <p:nvSpPr>
+          <p:cNvPr id="7" name="TextBox 6"/>
+          <p:cNvSpPr txBox="1"/>
+          <p:nvPr/>
+        </p:nvSpPr>
+        <p:spPr>
+          <a:xfrm>
+            <a:off x="914400" y="4524375"/>
+            <a:ext cx="7239000" cy="371475"/>
+          </a:xfrm>
+          <a:prstGeom prst="rect">
+            <a:avLst/>
+          </a:prstGeom>
+          <a:noFill/>
+        </p:spPr>
+        <p:txBody>
+          <a:bodyPr wrap="square" lIns="0" rIns="0" tIns="0" bIns="0" anchor="t">
+            <a:spAutoFit/>
+          </a:bodyPr>
+          <a:lstStyle/>
           <a:p>
             <a:pPr algn="l">
               <a:lnSpc>
                 <a:spcPct val="125000"/>
               </a:lnSpc>
-              <a:spcAft>
-                <a:spcPts val="2550"/>
-              </a:spcAft>
             </a:pPr>
             <a:r>
               <a:rPr sz="2250" b="1" i="0">
@@ -19128,14 +19524,34 @@
               <a:t> are rules, like Max Velocity</a:t>
             </a:r>
           </a:p>
+        </p:txBody>
+      </p:sp>
+      <p:sp>
+        <p:nvSpPr>
+          <p:cNvPr id="8" name="TextBox 7"/>
+          <p:cNvSpPr txBox="1"/>
+          <p:nvPr/>
+        </p:nvSpPr>
+        <p:spPr>
+          <a:xfrm>
+            <a:off x="914400" y="5219700"/>
+            <a:ext cx="7239000" cy="371475"/>
+          </a:xfrm>
+          <a:prstGeom prst="rect">
+            <a:avLst/>
+          </a:prstGeom>
+          <a:noFill/>
+        </p:spPr>
+        <p:txBody>
+          <a:bodyPr wrap="square" lIns="0" rIns="0" tIns="0" bIns="0" anchor="t">
+            <a:spAutoFit/>
+          </a:bodyPr>
+          <a:lstStyle/>
           <a:p>
             <a:pPr algn="l">
               <a:lnSpc>
                 <a:spcPct val="125000"/>
               </a:lnSpc>
-              <a:spcAft>
-                <a:spcPts val="2550"/>
-              </a:spcAft>
             </a:pPr>
             <a:r>
               <a:rPr sz="2250" b="1" i="0">
@@ -19175,7 +19591,7 @@
       </p:sp>
       <p:sp>
         <p:nvSpPr>
-          <p:cNvPr id="6" name="Rectangle 5"/>
+          <p:cNvPr id="9" name="Rectangle 8"/>
           <p:cNvSpPr/>
           <p:nvPr/>
         </p:nvSpPr>
@@ -19219,7 +19635,7 @@
       </p:sp>
       <p:pic>
         <p:nvPicPr>
-          <p:cNvPr id="7" name="Picture 6" descr="choreo.png"/>
+          <p:cNvPr id="10" name="Picture 9" descr="choreo.png"/>
           <p:cNvPicPr>
             <a:picLocks noChangeAspect="1"/>
           </p:cNvPicPr>
@@ -19243,7 +19659,7 @@
       </p:pic>
       <p:sp>
         <p:nvSpPr>
-          <p:cNvPr id="8" name="Rectangle 7"/>
+          <p:cNvPr id="11" name="Rectangle 10"/>
           <p:cNvSpPr/>
           <p:nvPr/>
         </p:nvSpPr>
@@ -19285,7 +19701,7 @@
       </p:sp>
       <p:pic>
         <p:nvPicPr>
-          <p:cNvPr id="9" name="Picture 8" descr="mw_logo_small.png"/>
+          <p:cNvPr id="12" name="Picture 11" descr="mw_logo_small.png"/>
           <p:cNvPicPr>
             <a:picLocks noChangeAspect="1"/>
           </p:cNvPicPr>
@@ -19309,7 +19725,7 @@
       </p:pic>
       <p:sp>
         <p:nvSpPr>
-          <p:cNvPr id="10" name="TextBox 9"/>
+          <p:cNvPr id="13" name="TextBox 12"/>
           <p:cNvSpPr txBox="1"/>
           <p:nvPr/>
         </p:nvSpPr>
@@ -20984,7 +21400,7 @@
         <p:spPr>
           <a:xfrm>
             <a:off x="914400" y="2762250"/>
-            <a:ext cx="6096000" cy="5715000"/>
+            <a:ext cx="6096000" cy="371475"/>
           </a:xfrm>
           <a:prstGeom prst="rect">
             <a:avLst/>
@@ -21001,9 +21417,6 @@
               <a:lnSpc>
                 <a:spcPct val="125000"/>
               </a:lnSpc>
-              <a:spcAft>
-                <a:spcPts val="2550"/>
-              </a:spcAft>
             </a:pPr>
             <a:r>
               <a:rPr sz="2250" b="1" i="0">
@@ -21028,14 +21441,34 @@
               <a:t>Open it in a browser: nothing to install</a:t>
             </a:r>
           </a:p>
+        </p:txBody>
+      </p:sp>
+      <p:sp>
+        <p:nvSpPr>
+          <p:cNvPr id="6" name="TextBox 5"/>
+          <p:cNvSpPr txBox="1"/>
+          <p:nvPr/>
+        </p:nvSpPr>
+        <p:spPr>
+          <a:xfrm>
+            <a:off x="914400" y="3457575"/>
+            <a:ext cx="6096000" cy="742950"/>
+          </a:xfrm>
+          <a:prstGeom prst="rect">
+            <a:avLst/>
+          </a:prstGeom>
+          <a:noFill/>
+        </p:spPr>
+        <p:txBody>
+          <a:bodyPr wrap="square" lIns="0" rIns="0" tIns="0" bIns="0" anchor="t">
+            <a:spAutoFit/>
+          </a:bodyPr>
+          <a:lstStyle/>
           <a:p>
             <a:pPr algn="l">
               <a:lnSpc>
                 <a:spcPct val="125000"/>
               </a:lnSpc>
-              <a:spcAft>
-                <a:spcPts val="2550"/>
-              </a:spcAft>
             </a:pPr>
             <a:r>
               <a:rPr sz="2250" b="1" i="0">
@@ -21060,14 +21493,34 @@
               <a:t>The lesson chip at the top holds your checkpoints</a:t>
             </a:r>
           </a:p>
+        </p:txBody>
+      </p:sp>
+      <p:sp>
+        <p:nvSpPr>
+          <p:cNvPr id="7" name="TextBox 6"/>
+          <p:cNvSpPr txBox="1"/>
+          <p:nvPr/>
+        </p:nvSpPr>
+        <p:spPr>
+          <a:xfrm>
+            <a:off x="914400" y="4524375"/>
+            <a:ext cx="6096000" cy="371475"/>
+          </a:xfrm>
+          <a:prstGeom prst="rect">
+            <a:avLst/>
+          </a:prstGeom>
+          <a:noFill/>
+        </p:spPr>
+        <p:txBody>
+          <a:bodyPr wrap="square" lIns="0" rIns="0" tIns="0" bIns="0" anchor="t">
+            <a:spAutoFit/>
+          </a:bodyPr>
+          <a:lstStyle/>
           <a:p>
             <a:pPr algn="l">
               <a:lnSpc>
                 <a:spcPct val="125000"/>
               </a:lnSpc>
-              <a:spcAft>
-                <a:spcPts val="2550"/>
-              </a:spcAft>
             </a:pPr>
             <a:r>
               <a:rPr sz="2250" b="1" i="0">
@@ -21092,14 +21545,34 @@
               <a:t>Preview shows the lesson's instructions</a:t>
             </a:r>
           </a:p>
+        </p:txBody>
+      </p:sp>
+      <p:sp>
+        <p:nvSpPr>
+          <p:cNvPr id="8" name="TextBox 7"/>
+          <p:cNvSpPr txBox="1"/>
+          <p:nvPr/>
+        </p:nvSpPr>
+        <p:spPr>
+          <a:xfrm>
+            <a:off x="914400" y="5219700"/>
+            <a:ext cx="6096000" cy="371475"/>
+          </a:xfrm>
+          <a:prstGeom prst="rect">
+            <a:avLst/>
+          </a:prstGeom>
+          <a:noFill/>
+        </p:spPr>
+        <p:txBody>
+          <a:bodyPr wrap="square" lIns="0" rIns="0" tIns="0" bIns="0" anchor="t">
+            <a:spAutoFit/>
+          </a:bodyPr>
+          <a:lstStyle/>
           <a:p>
             <a:pPr algn="l">
               <a:lnSpc>
                 <a:spcPct val="125000"/>
               </a:lnSpc>
-              <a:spcAft>
-                <a:spcPts val="2550"/>
-              </a:spcAft>
             </a:pPr>
             <a:r>
               <a:rPr sz="2250" b="1" i="0">
@@ -21128,7 +21601,7 @@
       </p:sp>
       <p:sp>
         <p:nvSpPr>
-          <p:cNvPr id="6" name="Rectangle 5"/>
+          <p:cNvPr id="9" name="Rectangle 8"/>
           <p:cNvSpPr/>
           <p:nvPr/>
         </p:nvSpPr>
@@ -21172,7 +21645,7 @@
       </p:sp>
       <p:pic>
         <p:nvPicPr>
-          <p:cNvPr id="7" name="Picture 6" descr="welcome.png"/>
+          <p:cNvPr id="10" name="Picture 9" descr="welcome.png"/>
           <p:cNvPicPr>
             <a:picLocks noChangeAspect="1"/>
           </p:cNvPicPr>
@@ -21196,7 +21669,7 @@
       </p:pic>
       <p:sp>
         <p:nvSpPr>
-          <p:cNvPr id="8" name="Rectangle 7"/>
+          <p:cNvPr id="11" name="Rectangle 10"/>
           <p:cNvSpPr/>
           <p:nvPr/>
         </p:nvSpPr>
@@ -21238,7 +21711,7 @@
       </p:sp>
       <p:sp>
         <p:nvSpPr>
-          <p:cNvPr id="9" name="TextBox 8"/>
+          <p:cNvPr id="12" name="TextBox 11"/>
           <p:cNvSpPr txBox="1"/>
           <p:nvPr/>
         </p:nvSpPr>
@@ -21275,7 +21748,7 @@
       </p:sp>
       <p:pic>
         <p:nvPicPr>
-          <p:cNvPr id="10" name="Picture 9" descr="mw_logo_small.png"/>
+          <p:cNvPr id="13" name="Picture 12" descr="mw_logo_small.png"/>
           <p:cNvPicPr>
             <a:picLocks noChangeAspect="1"/>
           </p:cNvPicPr>
@@ -21299,7 +21772,7 @@
       </p:pic>
       <p:sp>
         <p:nvSpPr>
-          <p:cNvPr id="11" name="TextBox 10"/>
+          <p:cNvPr id="14" name="TextBox 13"/>
           <p:cNvSpPr txBox="1"/>
           <p:nvPr/>
         </p:nvSpPr>
@@ -21942,7 +22415,7 @@
         <p:spPr>
           <a:xfrm>
             <a:off x="12496800" y="3810000"/>
-            <a:ext cx="533400" cy="533400"/>
+            <a:ext cx="571500" cy="533400"/>
           </a:xfrm>
           <a:prstGeom prst="rect">
             <a:avLst/>
@@ -23874,7 +24347,7 @@
         <p:spPr>
           <a:xfrm>
             <a:off x="914400" y="2762250"/>
-            <a:ext cx="16459200" cy="5715000"/>
+            <a:ext cx="16459200" cy="396240"/>
           </a:xfrm>
           <a:prstGeom prst="rect">
             <a:avLst/>
@@ -23891,9 +24364,6 @@
               <a:lnSpc>
                 <a:spcPct val="125000"/>
               </a:lnSpc>
-              <a:spcAft>
-                <a:spcPts val="1650"/>
-              </a:spcAft>
             </a:pPr>
             <a:r>
               <a:rPr sz="2400" b="1" i="0">
@@ -23918,14 +24388,34 @@
               <a:t>A file has a name and an extension: Robot.java</a:t>
             </a:r>
           </a:p>
+        </p:txBody>
+      </p:sp>
+      <p:sp>
+        <p:nvSpPr>
+          <p:cNvPr id="6" name="TextBox 5"/>
+          <p:cNvSpPr txBox="1"/>
+          <p:nvPr/>
+        </p:nvSpPr>
+        <p:spPr>
+          <a:xfrm>
+            <a:off x="914400" y="3368040"/>
+            <a:ext cx="16459200" cy="396240"/>
+          </a:xfrm>
+          <a:prstGeom prst="rect">
+            <a:avLst/>
+          </a:prstGeom>
+          <a:noFill/>
+        </p:spPr>
+        <p:txBody>
+          <a:bodyPr wrap="square" lIns="0" rIns="0" tIns="0" bIns="0" anchor="t">
+            <a:spAutoFit/>
+          </a:bodyPr>
+          <a:lstStyle/>
           <a:p>
             <a:pPr algn="l">
               <a:lnSpc>
                 <a:spcPct val="125000"/>
               </a:lnSpc>
-              <a:spcAft>
-                <a:spcPts val="1650"/>
-              </a:spcAft>
             </a:pPr>
             <a:r>
               <a:rPr sz="2400" b="1" i="0">
@@ -23950,14 +24440,34 @@
               <a:t>A folder holds files and other folders</a:t>
             </a:r>
           </a:p>
+        </p:txBody>
+      </p:sp>
+      <p:sp>
+        <p:nvSpPr>
+          <p:cNvPr id="7" name="TextBox 6"/>
+          <p:cNvSpPr txBox="1"/>
+          <p:nvPr/>
+        </p:nvSpPr>
+        <p:spPr>
+          <a:xfrm>
+            <a:off x="914400" y="3973830"/>
+            <a:ext cx="16459200" cy="396240"/>
+          </a:xfrm>
+          <a:prstGeom prst="rect">
+            <a:avLst/>
+          </a:prstGeom>
+          <a:noFill/>
+        </p:spPr>
+        <p:txBody>
+          <a:bodyPr wrap="square" lIns="0" rIns="0" tIns="0" bIns="0" anchor="t">
+            <a:spAutoFit/>
+          </a:bodyPr>
+          <a:lstStyle/>
           <a:p>
             <a:pPr algn="l">
               <a:lnSpc>
                 <a:spcPct val="125000"/>
               </a:lnSpc>
-              <a:spcAft>
-                <a:spcPts val="1650"/>
-              </a:spcAft>
             </a:pPr>
             <a:r>
               <a:rPr sz="2400" b="1" i="0">
@@ -23982,14 +24492,34 @@
               <a:t>A project is one folder with everything inside</a:t>
             </a:r>
           </a:p>
+        </p:txBody>
+      </p:sp>
+      <p:sp>
+        <p:nvSpPr>
+          <p:cNvPr id="8" name="TextBox 7"/>
+          <p:cNvSpPr txBox="1"/>
+          <p:nvPr/>
+        </p:nvSpPr>
+        <p:spPr>
+          <a:xfrm>
+            <a:off x="914400" y="4579620"/>
+            <a:ext cx="16459200" cy="396240"/>
+          </a:xfrm>
+          <a:prstGeom prst="rect">
+            <a:avLst/>
+          </a:prstGeom>
+          <a:noFill/>
+        </p:spPr>
+        <p:txBody>
+          <a:bodyPr wrap="square" lIns="0" rIns="0" tIns="0" bIns="0" anchor="t">
+            <a:spAutoFit/>
+          </a:bodyPr>
+          <a:lstStyle/>
           <a:p>
             <a:pPr algn="l">
               <a:lnSpc>
                 <a:spcPct val="125000"/>
               </a:lnSpc>
-              <a:spcAft>
-                <a:spcPts val="1650"/>
-              </a:spcAft>
             </a:pPr>
             <a:r>
               <a:rPr sz="2400" b="1" i="0">
@@ -24018,7 +24548,7 @@
       </p:sp>
       <p:sp>
         <p:nvSpPr>
-          <p:cNvPr id="6" name="Rounded Rectangle 5"/>
+          <p:cNvPr id="9" name="Rounded Rectangle 8"/>
           <p:cNvSpPr/>
           <p:nvPr/>
         </p:nvSpPr>
@@ -24064,7 +24594,7 @@
       </p:sp>
       <p:sp>
         <p:nvSpPr>
-          <p:cNvPr id="7" name="TextBox 6"/>
+          <p:cNvPr id="10" name="TextBox 9"/>
           <p:cNvSpPr txBox="1"/>
           <p:nvPr/>
         </p:nvSpPr>
@@ -24222,7 +24752,7 @@
       </p:sp>
       <p:sp>
         <p:nvSpPr>
-          <p:cNvPr id="8" name="TextBox 7"/>
+          <p:cNvPr id="11" name="TextBox 10"/>
           <p:cNvSpPr txBox="1"/>
           <p:nvPr/>
         </p:nvSpPr>
@@ -24259,7 +24789,7 @@
       </p:sp>
       <p:pic>
         <p:nvPicPr>
-          <p:cNvPr id="9" name="Picture 8" descr="mw_logo_small.png"/>
+          <p:cNvPr id="12" name="Picture 11" descr="mw_logo_small.png"/>
           <p:cNvPicPr>
             <a:picLocks noChangeAspect="1"/>
           </p:cNvPicPr>
@@ -24283,7 +24813,7 @@
       </p:pic>
       <p:sp>
         <p:nvSpPr>
-          <p:cNvPr id="10" name="TextBox 9"/>
+          <p:cNvPr id="13" name="TextBox 12"/>
           <p:cNvSpPr txBox="1"/>
           <p:nvPr/>
         </p:nvSpPr>

</xml_diff>